<commit_message>
change something for ppt
</commit_message>
<xml_diff>
--- a/docs/Presentation.pptx
+++ b/docs/Presentation.pptx
@@ -13120,10 +13120,10 @@
                 <a:solidFill>
                   <a:srgbClr val="FFFFFF"/>
                 </a:solidFill>
-                <a:latin typeface="Songti SC"/>
-                <a:ea typeface="Songti SC"/>
-                <a:cs typeface="Songti SC"/>
-                <a:sym typeface="Songti SC"/>
+                <a:latin typeface="Arial" panose="020B0604020202020204"/>
+                <a:ea typeface="Arial" panose="020B0604020202020204"/>
+                <a:cs typeface="Arial" panose="020B0604020202020204"/>
+                <a:sym typeface="Arial" panose="020B0604020202020204"/>
               </a:rPr>
               <a:t>Habit Tracker API</a:t>
             </a:r>
@@ -13169,10 +13169,10 @@
                     <a:alpha val="94902"/>
                   </a:srgbClr>
                 </a:solidFill>
-                <a:latin typeface="Songti SC"/>
-                <a:ea typeface="Songti SC"/>
-                <a:cs typeface="Songti SC"/>
-                <a:sym typeface="Songti SC"/>
+                <a:latin typeface="Arial" panose="020B0604020202020204"/>
+                <a:ea typeface="Arial" panose="020B0604020202020204"/>
+                <a:cs typeface="Arial" panose="020B0604020202020204"/>
+                <a:sym typeface="Arial" panose="020B0604020202020204"/>
               </a:rPr>
               <a:t>A RESTful Service for Personal Habit Management</a:t>
             </a:r>
@@ -13218,10 +13218,10 @@
                     <a:alpha val="80000"/>
                   </a:srgbClr>
                 </a:solidFill>
-                <a:latin typeface="Songti SC"/>
-                <a:ea typeface="Songti SC"/>
-                <a:cs typeface="Songti SC"/>
-                <a:sym typeface="Songti SC"/>
+                <a:latin typeface="Arial" panose="020B0604020202020204"/>
+                <a:ea typeface="Arial" panose="020B0604020202020204"/>
+                <a:cs typeface="Arial" panose="020B0604020202020204"/>
+                <a:sym typeface="Arial" panose="020B0604020202020204"/>
               </a:rPr>
               <a:t>COURSEWORK PROJECT | WEB SERVICES AND WEB DATA</a:t>
             </a:r>
@@ -13341,10 +13341,10 @@
                 <a:solidFill>
                   <a:srgbClr val="333333"/>
                 </a:solidFill>
-                <a:latin typeface="Songti SC"/>
-                <a:ea typeface="Songti SC"/>
-                <a:cs typeface="Songti SC"/>
-                <a:sym typeface="Songti SC"/>
+                <a:latin typeface="Arial" panose="020B0604020202020204"/>
+                <a:ea typeface="Arial" panose="020B0604020202020204"/>
+                <a:cs typeface="Arial" panose="020B0604020202020204"/>
+                <a:sym typeface="Arial" panose="020B0604020202020204"/>
               </a:rPr>
               <a:t>Project Overview: Purpose and Scope</a:t>
             </a:r>
@@ -13465,10 +13465,10 @@
                 <a:solidFill>
                   <a:srgbClr val="1ABC9C"/>
                 </a:solidFill>
-                <a:latin typeface="Songti SC"/>
-                <a:ea typeface="Songti SC"/>
-                <a:cs typeface="Songti SC"/>
-                <a:sym typeface="Songti SC"/>
+                <a:latin typeface="Arial" panose="020B0604020202020204"/>
+                <a:ea typeface="Arial" panose="020B0604020202020204"/>
+                <a:cs typeface="Arial" panose="020B0604020202020204"/>
+                <a:sym typeface="Arial" panose="020B0604020202020204"/>
               </a:rPr>
               <a:t>CORE OBJECTIVE</a:t>
             </a:r>
@@ -13512,10 +13512,10 @@
                 <a:solidFill>
                   <a:srgbClr val="555555"/>
                 </a:solidFill>
-                <a:latin typeface="Songti SC"/>
-                <a:ea typeface="Songti SC"/>
-                <a:cs typeface="Songti SC"/>
-                <a:sym typeface="Songti SC"/>
+                <a:latin typeface="Arial" panose="020B0604020202020204"/>
+                <a:ea typeface="Arial" panose="020B0604020202020204"/>
+                <a:cs typeface="Arial" panose="020B0604020202020204"/>
+                <a:sym typeface="Arial" panose="020B0604020202020204"/>
               </a:rPr>
               <a:t>Design and implement a robust, scalable, and well-documented RESTful API to facilitate comprehensive habit tracking.</a:t>
             </a:r>
@@ -13636,10 +13636,10 @@
                 <a:solidFill>
                   <a:srgbClr val="1ABC9C"/>
                 </a:solidFill>
-                <a:latin typeface="Songti SC"/>
-                <a:ea typeface="Songti SC"/>
-                <a:cs typeface="Songti SC"/>
-                <a:sym typeface="Songti SC"/>
+                <a:latin typeface="Arial" panose="020B0604020202020204"/>
+                <a:ea typeface="Arial" panose="020B0604020202020204"/>
+                <a:cs typeface="Arial" panose="020B0604020202020204"/>
+                <a:sym typeface="Arial" panose="020B0604020202020204"/>
               </a:rPr>
               <a:t>KEY FUNCTIONALITY</a:t>
             </a:r>
@@ -13683,10 +13683,10 @@
                 <a:solidFill>
                   <a:srgbClr val="555555"/>
                 </a:solidFill>
-                <a:latin typeface="Songti SC"/>
-                <a:ea typeface="Songti SC"/>
-                <a:cs typeface="Songti SC"/>
-                <a:sym typeface="Songti SC"/>
+                <a:latin typeface="Arial" panose="020B0604020202020204"/>
+                <a:ea typeface="Arial" panose="020B0604020202020204"/>
+                <a:cs typeface="Arial" panose="020B0604020202020204"/>
+                <a:sym typeface="Arial" panose="020B0604020202020204"/>
               </a:rPr>
               <a:t>• CRUD Operations for Habit Management | • Data Validation &amp; Integrity</a:t>
             </a:r>
@@ -13695,10 +13695,10 @@
                 <a:solidFill>
                   <a:srgbClr val="555555"/>
                 </a:solidFill>
-                <a:latin typeface="Songti SC"/>
-                <a:ea typeface="Songti SC"/>
-                <a:cs typeface="Songti SC"/>
-                <a:sym typeface="Songti SC"/>
+                <a:latin typeface="Arial" panose="020B0604020202020204"/>
+                <a:ea typeface="Arial" panose="020B0604020202020204"/>
+                <a:cs typeface="Arial" panose="020B0604020202020204"/>
+                <a:sym typeface="Arial" panose="020B0604020202020204"/>
               </a:rPr>
             </a:br>
             <a:r>
@@ -13706,10 +13706,10 @@
                 <a:solidFill>
                   <a:srgbClr val="555555"/>
                 </a:solidFill>
-                <a:latin typeface="Songti SC"/>
-                <a:ea typeface="Songti SC"/>
-                <a:cs typeface="Songti SC"/>
-                <a:sym typeface="Songti SC"/>
+                <a:latin typeface="Arial" panose="020B0604020202020204"/>
+                <a:ea typeface="Arial" panose="020B0604020202020204"/>
+                <a:cs typeface="Arial" panose="020B0604020202020204"/>
+                <a:sym typeface="Arial" panose="020B0604020202020204"/>
               </a:rPr>
               <a:t>• Real-time Statistics (Streaks/Rates) | • Comprehensive API Docs</a:t>
             </a:r>
@@ -13830,10 +13830,10 @@
                 <a:solidFill>
                   <a:srgbClr val="1ABC9C"/>
                 </a:solidFill>
-                <a:latin typeface="Songti SC"/>
-                <a:ea typeface="Songti SC"/>
-                <a:cs typeface="Songti SC"/>
-                <a:sym typeface="Songti SC"/>
+                <a:latin typeface="Arial" panose="020B0604020202020204"/>
+                <a:ea typeface="Arial" panose="020B0604020202020204"/>
+                <a:cs typeface="Arial" panose="020B0604020202020204"/>
+                <a:sym typeface="Arial" panose="020B0604020202020204"/>
               </a:rPr>
               <a:t>TARGET AUDIENCE</a:t>
             </a:r>
@@ -13877,10 +13877,10 @@
                 <a:solidFill>
                   <a:srgbClr val="555555"/>
                 </a:solidFill>
-                <a:latin typeface="Songti SC"/>
-                <a:ea typeface="Songti SC"/>
-                <a:cs typeface="Songti SC"/>
-                <a:sym typeface="Songti SC"/>
+                <a:latin typeface="Arial" panose="020B0604020202020204"/>
+                <a:ea typeface="Arial" panose="020B0604020202020204"/>
+                <a:cs typeface="Arial" panose="020B0604020202020204"/>
+                <a:sym typeface="Arial" panose="020B0604020202020204"/>
               </a:rPr>
               <a:t>Individuals seeking a reliable digital solution to monitor, analyze, and improve their daily habits.</a:t>
             </a:r>
@@ -14001,10 +14001,10 @@
                 <a:solidFill>
                   <a:srgbClr val="1ABC9C"/>
                 </a:solidFill>
-                <a:latin typeface="Songti SC"/>
-                <a:ea typeface="Songti SC"/>
-                <a:cs typeface="Songti SC"/>
-                <a:sym typeface="Songti SC"/>
+                <a:latin typeface="Arial" panose="020B0604020202020204"/>
+                <a:ea typeface="Arial" panose="020B0604020202020204"/>
+                <a:cs typeface="Arial" panose="020B0604020202020204"/>
+                <a:sym typeface="Arial" panose="020B0604020202020204"/>
               </a:rPr>
               <a:t>TECH STACK &amp; TOOLS</a:t>
             </a:r>
@@ -14048,10 +14048,10 @@
                 <a:solidFill>
                   <a:srgbClr val="666666"/>
                 </a:solidFill>
-                <a:latin typeface="Songti SC"/>
-                <a:ea typeface="Songti SC"/>
-                <a:cs typeface="Songti SC"/>
-                <a:sym typeface="Songti SC"/>
+                <a:latin typeface="Arial" panose="020B0604020202020204"/>
+                <a:ea typeface="Arial" panose="020B0604020202020204"/>
+                <a:cs typeface="Arial" panose="020B0604020202020204"/>
+                <a:sym typeface="Arial" panose="020B0604020202020204"/>
               </a:rPr>
               <a:t>Java 17 • Spring Boot • Spring Data JPA • H2 DB • Jakarta Validation • OpenAPI</a:t>
             </a:r>
@@ -14172,10 +14172,10 @@
                 <a:solidFill>
                   <a:srgbClr val="333333"/>
                 </a:solidFill>
-                <a:latin typeface="Songti SC"/>
-                <a:ea typeface="Songti SC"/>
-                <a:cs typeface="Songti SC"/>
-                <a:sym typeface="Songti SC"/>
+                <a:latin typeface="Arial" panose="020B0604020202020204"/>
+                <a:ea typeface="Arial" panose="020B0604020202020204"/>
+                <a:cs typeface="Arial" panose="020B0604020202020204"/>
+                <a:sym typeface="Arial" panose="020B0604020202020204"/>
               </a:rPr>
               <a:t>System Architecture Diagram</a:t>
             </a:r>
@@ -14192,10 +14192,10 @@
                 <a:solidFill>
                   <a:srgbClr val="808080"/>
                 </a:solidFill>
-                <a:latin typeface="Songti SC"/>
-                <a:ea typeface="Songti SC"/>
-                <a:cs typeface="Songti SC"/>
-                <a:sym typeface="Songti SC"/>
+                <a:latin typeface="Arial" panose="020B0604020202020204"/>
+                <a:ea typeface="Arial" panose="020B0604020202020204"/>
+                <a:cs typeface="Arial" panose="020B0604020202020204"/>
+                <a:sym typeface="Arial" panose="020B0604020202020204"/>
               </a:rPr>
               <a:t>Client-Server Interaction Model</a:t>
             </a:r>
@@ -14203,10 +14203,10 @@
               <a:solidFill>
                 <a:srgbClr val="808080"/>
               </a:solidFill>
-              <a:latin typeface="Songti SC"/>
-              <a:ea typeface="Songti SC"/>
-              <a:cs typeface="Songti SC"/>
-              <a:sym typeface="Songti SC"/>
+              <a:latin typeface="Arial" panose="020B0604020202020204"/>
+              <a:ea typeface="Arial" panose="020B0604020202020204"/>
+              <a:cs typeface="Arial" panose="020B0604020202020204"/>
+              <a:sym typeface="Arial" panose="020B0604020202020204"/>
             </a:endParaRPr>
           </a:p>
         </p:txBody>
@@ -14323,10 +14323,10 @@
                 <a:solidFill>
                   <a:srgbClr val="333333"/>
                 </a:solidFill>
-                <a:latin typeface="Songti SC"/>
-                <a:ea typeface="Songti SC"/>
-                <a:cs typeface="Songti SC"/>
-                <a:sym typeface="Songti SC"/>
+                <a:latin typeface="Arial" panose="020B0604020202020204"/>
+                <a:ea typeface="Arial" panose="020B0604020202020204"/>
+                <a:cs typeface="Arial" panose="020B0604020202020204"/>
+                <a:sym typeface="Arial" panose="020B0604020202020204"/>
               </a:rPr>
               <a:t>Architecture and Project Structure</a:t>
             </a:r>
@@ -14414,10 +14414,10 @@
                 <a:solidFill>
                   <a:srgbClr val="1ABC9C"/>
                 </a:solidFill>
-                <a:latin typeface="Songti SC"/>
-                <a:ea typeface="Songti SC"/>
-                <a:cs typeface="Songti SC"/>
-                <a:sym typeface="Songti SC"/>
+                <a:latin typeface="Arial" panose="020B0604020202020204"/>
+                <a:ea typeface="Arial" panose="020B0604020202020204"/>
+                <a:cs typeface="Arial" panose="020B0604020202020204"/>
+                <a:sym typeface="Arial" panose="020B0604020202020204"/>
               </a:rPr>
               <a:t>Architectural Pattern</a:t>
             </a:r>
@@ -14461,10 +14461,10 @@
                 <a:solidFill>
                   <a:srgbClr val="555555"/>
                 </a:solidFill>
-                <a:latin typeface="Songti SC"/>
-                <a:ea typeface="Songti SC"/>
-                <a:cs typeface="Songti SC"/>
-                <a:sym typeface="Songti SC"/>
+                <a:latin typeface="Arial" panose="020B0604020202020204"/>
+                <a:ea typeface="Arial" panose="020B0604020202020204"/>
+                <a:cs typeface="Arial" panose="020B0604020202020204"/>
+                <a:sym typeface="Arial" panose="020B0604020202020204"/>
               </a:rPr>
               <a:t>The application is built on a robust layered architecture, strictly adhering to the MVC (Model-View-Controller) design pattern for separation of concerns.</a:t>
             </a:r>
@@ -14545,10 +14545,10 @@
                 <a:solidFill>
                   <a:srgbClr val="1ABC9C"/>
                 </a:solidFill>
-                <a:latin typeface="Songti SC"/>
-                <a:ea typeface="Songti SC"/>
-                <a:cs typeface="Songti SC"/>
-                <a:sym typeface="Songti SC"/>
+                <a:latin typeface="Arial" panose="020B0604020202020204"/>
+                <a:ea typeface="Arial" panose="020B0604020202020204"/>
+                <a:cs typeface="Arial" panose="020B0604020202020204"/>
+                <a:sym typeface="Arial" panose="020B0604020202020204"/>
               </a:rPr>
               <a:t>Data Flow:</a:t>
             </a:r>
@@ -14557,10 +14557,10 @@
                 <a:solidFill>
                   <a:srgbClr val="3C3C3C"/>
                 </a:solidFill>
-                <a:latin typeface="Songti SC"/>
-                <a:ea typeface="Songti SC"/>
-                <a:cs typeface="Songti SC"/>
-                <a:sym typeface="Songti SC"/>
+                <a:latin typeface="Arial" panose="020B0604020202020204"/>
+                <a:ea typeface="Arial" panose="020B0604020202020204"/>
+                <a:cs typeface="Arial" panose="020B0604020202020204"/>
+                <a:sym typeface="Arial" panose="020B0604020202020204"/>
               </a:rPr>
               <a:t>Client → Controller → Service → Repository → Database</a:t>
             </a:r>
@@ -14688,10 +14688,10 @@
                 <a:solidFill>
                   <a:srgbClr val="1ABC9C"/>
                 </a:solidFill>
-                <a:latin typeface="Songti SC"/>
-                <a:ea typeface="Songti SC"/>
-                <a:cs typeface="Songti SC"/>
-                <a:sym typeface="Songti SC"/>
+                <a:latin typeface="Arial" panose="020B0604020202020204"/>
+                <a:ea typeface="Arial" panose="020B0604020202020204"/>
+                <a:cs typeface="Arial" panose="020B0604020202020204"/>
+                <a:sym typeface="Arial" panose="020B0604020202020204"/>
               </a:rPr>
               <a:t>Core Packages &amp; Responsibilities</a:t>
             </a:r>
@@ -14776,10 +14776,10 @@
                 <a:solidFill>
                   <a:srgbClr val="1ABC9C"/>
                 </a:solidFill>
-                <a:latin typeface="Songti SC"/>
-                <a:ea typeface="Songti SC"/>
-                <a:cs typeface="Songti SC"/>
-                <a:sym typeface="Songti SC"/>
+                <a:latin typeface="Arial" panose="020B0604020202020204"/>
+                <a:ea typeface="Arial" panose="020B0604020202020204"/>
+                <a:cs typeface="Arial" panose="020B0604020202020204"/>
+                <a:sym typeface="Arial" panose="020B0604020202020204"/>
               </a:rPr>
               <a:t>/ controller</a:t>
             </a:r>
@@ -14823,10 +14823,10 @@
                 <a:solidFill>
                   <a:srgbClr val="666666"/>
                 </a:solidFill>
-                <a:latin typeface="Songti SC"/>
-                <a:ea typeface="Songti SC"/>
-                <a:cs typeface="Songti SC"/>
-                <a:sym typeface="Songti SC"/>
+                <a:latin typeface="Arial" panose="020B0604020202020204"/>
+                <a:ea typeface="Arial" panose="020B0604020202020204"/>
+                <a:cs typeface="Arial" panose="020B0604020202020204"/>
+                <a:sym typeface="Arial" panose="020B0604020202020204"/>
               </a:rPr>
               <a:t>Entry point for HTTP requests/responses; maps endpoints to service logic.</a:t>
             </a:r>
@@ -14911,10 +14911,10 @@
                 <a:solidFill>
                   <a:srgbClr val="1ABC9C"/>
                 </a:solidFill>
-                <a:latin typeface="Songti SC"/>
-                <a:ea typeface="Songti SC"/>
-                <a:cs typeface="Songti SC"/>
-                <a:sym typeface="Songti SC"/>
+                <a:latin typeface="Arial" panose="020B0604020202020204"/>
+                <a:ea typeface="Arial" panose="020B0604020202020204"/>
+                <a:cs typeface="Arial" panose="020B0604020202020204"/>
+                <a:sym typeface="Arial" panose="020B0604020202020204"/>
               </a:rPr>
               <a:t>/ service</a:t>
             </a:r>
@@ -14958,10 +14958,10 @@
                 <a:solidFill>
                   <a:srgbClr val="666666"/>
                 </a:solidFill>
-                <a:latin typeface="Songti SC"/>
-                <a:ea typeface="Songti SC"/>
-                <a:cs typeface="Songti SC"/>
-                <a:sym typeface="Songti SC"/>
+                <a:latin typeface="Arial" panose="020B0604020202020204"/>
+                <a:ea typeface="Arial" panose="020B0604020202020204"/>
+                <a:cs typeface="Arial" panose="020B0604020202020204"/>
+                <a:sym typeface="Arial" panose="020B0604020202020204"/>
               </a:rPr>
               <a:t>Contains core business logic, validations, and orchestrates data flow between layers.</a:t>
             </a:r>
@@ -15046,10 +15046,10 @@
                 <a:solidFill>
                   <a:srgbClr val="1ABC9C"/>
                 </a:solidFill>
-                <a:latin typeface="Songti SC"/>
-                <a:ea typeface="Songti SC"/>
-                <a:cs typeface="Songti SC"/>
-                <a:sym typeface="Songti SC"/>
+                <a:latin typeface="Arial" panose="020B0604020202020204"/>
+                <a:ea typeface="Arial" panose="020B0604020202020204"/>
+                <a:cs typeface="Arial" panose="020B0604020202020204"/>
+                <a:sym typeface="Arial" panose="020B0604020202020204"/>
               </a:rPr>
               <a:t>/ repository</a:t>
             </a:r>
@@ -15093,10 +15093,10 @@
                 <a:solidFill>
                   <a:srgbClr val="666666"/>
                 </a:solidFill>
-                <a:latin typeface="Songti SC"/>
-                <a:ea typeface="Songti SC"/>
-                <a:cs typeface="Songti SC"/>
-                <a:sym typeface="Songti SC"/>
+                <a:latin typeface="Arial" panose="020B0604020202020204"/>
+                <a:ea typeface="Arial" panose="020B0604020202020204"/>
+                <a:cs typeface="Arial" panose="020B0604020202020204"/>
+                <a:sym typeface="Arial" panose="020B0604020202020204"/>
               </a:rPr>
               <a:t>Data access layer using Spring Data JPA for seamless database interaction.</a:t>
             </a:r>
@@ -15181,10 +15181,10 @@
                 <a:solidFill>
                   <a:srgbClr val="1ABC9C"/>
                 </a:solidFill>
-                <a:latin typeface="Songti SC"/>
-                <a:ea typeface="Songti SC"/>
-                <a:cs typeface="Songti SC"/>
-                <a:sym typeface="Songti SC"/>
+                <a:latin typeface="Arial" panose="020B0604020202020204"/>
+                <a:ea typeface="Arial" panose="020B0604020202020204"/>
+                <a:cs typeface="Arial" panose="020B0604020202020204"/>
+                <a:sym typeface="Arial" panose="020B0604020202020204"/>
               </a:rPr>
               <a:t>/ model (Entity)</a:t>
             </a:r>
@@ -15228,10 +15228,10 @@
                 <a:solidFill>
                   <a:srgbClr val="666666"/>
                 </a:solidFill>
-                <a:latin typeface="Songti SC"/>
-                <a:ea typeface="Songti SC"/>
-                <a:cs typeface="Songti SC"/>
-                <a:sym typeface="Songti SC"/>
+                <a:latin typeface="Arial" panose="020B0604020202020204"/>
+                <a:ea typeface="Arial" panose="020B0604020202020204"/>
+                <a:cs typeface="Arial" panose="020B0604020202020204"/>
+                <a:sym typeface="Arial" panose="020B0604020202020204"/>
               </a:rPr>
               <a:t>Defines core domain entities (e.g., Habit, User) and their database mappings.</a:t>
             </a:r>
@@ -15316,10 +15316,10 @@
                 <a:solidFill>
                   <a:srgbClr val="1ABC9C"/>
                 </a:solidFill>
-                <a:latin typeface="Songti SC"/>
-                <a:ea typeface="Songti SC"/>
-                <a:cs typeface="Songti SC"/>
-                <a:sym typeface="Songti SC"/>
+                <a:latin typeface="Arial" panose="020B0604020202020204"/>
+                <a:ea typeface="Arial" panose="020B0604020202020204"/>
+                <a:cs typeface="Arial" panose="020B0604020202020204"/>
+                <a:sym typeface="Arial" panose="020B0604020202020204"/>
               </a:rPr>
               <a:t>/ dto (Data Transfer)</a:t>
             </a:r>
@@ -15363,10 +15363,10 @@
                 <a:solidFill>
                   <a:srgbClr val="666666"/>
                 </a:solidFill>
-                <a:latin typeface="Songti SC"/>
-                <a:ea typeface="Songti SC"/>
-                <a:cs typeface="Songti SC"/>
-                <a:sym typeface="Songti SC"/>
+                <a:latin typeface="Arial" panose="020B0604020202020204"/>
+                <a:ea typeface="Arial" panose="020B0604020202020204"/>
+                <a:cs typeface="Arial" panose="020B0604020202020204"/>
+                <a:sym typeface="Arial" panose="020B0604020202020204"/>
               </a:rPr>
               <a:t>Objects for secure and efficient communication between client and server layers.</a:t>
             </a:r>
@@ -15451,10 +15451,10 @@
                 <a:solidFill>
                   <a:srgbClr val="1ABC9C"/>
                 </a:solidFill>
-                <a:latin typeface="Songti SC"/>
-                <a:ea typeface="Songti SC"/>
-                <a:cs typeface="Songti SC"/>
-                <a:sym typeface="Songti SC"/>
+                <a:latin typeface="Arial" panose="020B0604020202020204"/>
+                <a:ea typeface="Arial" panose="020B0604020202020204"/>
+                <a:cs typeface="Arial" panose="020B0604020202020204"/>
+                <a:sym typeface="Arial" panose="020B0604020202020204"/>
               </a:rPr>
               <a:t>/ config &amp; /exception</a:t>
             </a:r>
@@ -15498,10 +15498,10 @@
                 <a:solidFill>
                   <a:srgbClr val="666666"/>
                 </a:solidFill>
-                <a:latin typeface="Songti SC"/>
-                <a:ea typeface="Songti SC"/>
-                <a:cs typeface="Songti SC"/>
-                <a:sym typeface="Songti SC"/>
+                <a:latin typeface="Arial" panose="020B0604020202020204"/>
+                <a:ea typeface="Arial" panose="020B0604020202020204"/>
+                <a:cs typeface="Arial" panose="020B0604020202020204"/>
+                <a:sym typeface="Arial" panose="020B0604020202020204"/>
               </a:rPr>
               <a:t>App configuration classes and a global handler for custom exceptions.</a:t>
             </a:r>
@@ -15621,10 +15621,10 @@
                 <a:solidFill>
                   <a:srgbClr val="333333"/>
                 </a:solidFill>
-                <a:latin typeface="Songti SC"/>
-                <a:ea typeface="Songti SC"/>
-                <a:cs typeface="Songti SC"/>
-                <a:sym typeface="Songti SC"/>
+                <a:latin typeface="Arial" panose="020B0604020202020204"/>
+                <a:ea typeface="Arial" panose="020B0604020202020204"/>
+                <a:cs typeface="Arial" panose="020B0604020202020204"/>
+                <a:sym typeface="Arial" panose="020B0604020202020204"/>
               </a:rPr>
               <a:t>Core API Endpoints</a:t>
             </a:r>
@@ -15712,10 +15712,10 @@
                 <a:solidFill>
                   <a:srgbClr val="1ABC9C"/>
                 </a:solidFill>
-                <a:latin typeface="Songti SC"/>
-                <a:ea typeface="Songti SC"/>
-                <a:cs typeface="Songti SC"/>
-                <a:sym typeface="Songti SC"/>
+                <a:latin typeface="Arial" panose="020B0604020202020204"/>
+                <a:ea typeface="Arial" panose="020B0604020202020204"/>
+                <a:cs typeface="Arial" panose="020B0604020202020204"/>
+                <a:sym typeface="Arial" panose="020B0604020202020204"/>
               </a:rPr>
               <a:t>Resource: /api/habits</a:t>
             </a:r>
@@ -15849,10 +15849,10 @@
                 <a:solidFill>
                   <a:srgbClr val="333333"/>
                 </a:solidFill>
-                <a:latin typeface="Songti SC"/>
-                <a:ea typeface="Songti SC"/>
-                <a:cs typeface="Songti SC"/>
-                <a:sym typeface="Songti SC"/>
+                <a:latin typeface="Arial" panose="020B0604020202020204"/>
+                <a:ea typeface="Arial" panose="020B0604020202020204"/>
+                <a:cs typeface="Arial" panose="020B0604020202020204"/>
+                <a:sym typeface="Arial" panose="020B0604020202020204"/>
               </a:rPr>
               <a:t>/api/habits</a:t>
             </a:r>
@@ -15896,10 +15896,10 @@
                 <a:solidFill>
                   <a:srgbClr val="666666"/>
                 </a:solidFill>
-                <a:latin typeface="Songti SC"/>
-                <a:ea typeface="Songti SC"/>
-                <a:cs typeface="Songti SC"/>
-                <a:sym typeface="Songti SC"/>
+                <a:latin typeface="Arial" panose="020B0604020202020204"/>
+                <a:ea typeface="Arial" panose="020B0604020202020204"/>
+                <a:cs typeface="Arial" panose="020B0604020202020204"/>
+                <a:sym typeface="Arial" panose="020B0604020202020204"/>
               </a:rPr>
               <a:t>Create a new habit</a:t>
             </a:r>
@@ -15996,10 +15996,10 @@
                 <a:solidFill>
                   <a:srgbClr val="333333"/>
                 </a:solidFill>
-                <a:latin typeface="Songti SC"/>
-                <a:ea typeface="Songti SC"/>
-                <a:cs typeface="Songti SC"/>
-                <a:sym typeface="Songti SC"/>
+                <a:latin typeface="Arial" panose="020B0604020202020204"/>
+                <a:ea typeface="Arial" panose="020B0604020202020204"/>
+                <a:cs typeface="Arial" panose="020B0604020202020204"/>
+                <a:sym typeface="Arial" panose="020B0604020202020204"/>
               </a:rPr>
               <a:t>/api/habits</a:t>
             </a:r>
@@ -16043,10 +16043,10 @@
                 <a:solidFill>
                   <a:srgbClr val="666666"/>
                 </a:solidFill>
-                <a:latin typeface="Songti SC"/>
-                <a:ea typeface="Songti SC"/>
-                <a:cs typeface="Songti SC"/>
-                <a:sym typeface="Songti SC"/>
+                <a:latin typeface="Arial" panose="020B0604020202020204"/>
+                <a:ea typeface="Arial" panose="020B0604020202020204"/>
+                <a:cs typeface="Arial" panose="020B0604020202020204"/>
+                <a:sym typeface="Arial" panose="020B0604020202020204"/>
               </a:rPr>
               <a:t>Retrieve all habits</a:t>
             </a:r>
@@ -16143,10 +16143,10 @@
                 <a:solidFill>
                   <a:srgbClr val="333333"/>
                 </a:solidFill>
-                <a:latin typeface="Songti SC"/>
-                <a:ea typeface="Songti SC"/>
-                <a:cs typeface="Songti SC"/>
-                <a:sym typeface="Songti SC"/>
+                <a:latin typeface="Arial" panose="020B0604020202020204"/>
+                <a:ea typeface="Arial" panose="020B0604020202020204"/>
+                <a:cs typeface="Arial" panose="020B0604020202020204"/>
+                <a:sym typeface="Arial" panose="020B0604020202020204"/>
               </a:rPr>
               <a:t>/habits/{id}</a:t>
             </a:r>
@@ -16190,10 +16190,10 @@
                 <a:solidFill>
                   <a:srgbClr val="666666"/>
                 </a:solidFill>
-                <a:latin typeface="Songti SC"/>
-                <a:ea typeface="Songti SC"/>
-                <a:cs typeface="Songti SC"/>
-                <a:sym typeface="Songti SC"/>
+                <a:latin typeface="Arial" panose="020B0604020202020204"/>
+                <a:ea typeface="Arial" panose="020B0604020202020204"/>
+                <a:cs typeface="Arial" panose="020B0604020202020204"/>
+                <a:sym typeface="Arial" panose="020B0604020202020204"/>
               </a:rPr>
               <a:t>Get habit by ID</a:t>
             </a:r>
@@ -16290,10 +16290,10 @@
                 <a:solidFill>
                   <a:srgbClr val="333333"/>
                 </a:solidFill>
-                <a:latin typeface="Songti SC"/>
-                <a:ea typeface="Songti SC"/>
-                <a:cs typeface="Songti SC"/>
-                <a:sym typeface="Songti SC"/>
+                <a:latin typeface="Arial" panose="020B0604020202020204"/>
+                <a:ea typeface="Arial" panose="020B0604020202020204"/>
+                <a:cs typeface="Arial" panose="020B0604020202020204"/>
+                <a:sym typeface="Arial" panose="020B0604020202020204"/>
               </a:rPr>
               <a:t>/habits/{id}</a:t>
             </a:r>
@@ -16337,10 +16337,10 @@
                 <a:solidFill>
                   <a:srgbClr val="666666"/>
                 </a:solidFill>
-                <a:latin typeface="Songti SC"/>
-                <a:ea typeface="Songti SC"/>
-                <a:cs typeface="Songti SC"/>
-                <a:sym typeface="Songti SC"/>
+                <a:latin typeface="Arial" panose="020B0604020202020204"/>
+                <a:ea typeface="Arial" panose="020B0604020202020204"/>
+                <a:cs typeface="Arial" panose="020B0604020202020204"/>
+                <a:sym typeface="Arial" panose="020B0604020202020204"/>
               </a:rPr>
               <a:t>Update existing habit</a:t>
             </a:r>
@@ -16437,10 +16437,10 @@
                 <a:solidFill>
                   <a:srgbClr val="333333"/>
                 </a:solidFill>
-                <a:latin typeface="Songti SC"/>
-                <a:ea typeface="Songti SC"/>
-                <a:cs typeface="Songti SC"/>
-                <a:sym typeface="Songti SC"/>
+                <a:latin typeface="Arial" panose="020B0604020202020204"/>
+                <a:ea typeface="Arial" panose="020B0604020202020204"/>
+                <a:cs typeface="Arial" panose="020B0604020202020204"/>
+                <a:sym typeface="Arial" panose="020B0604020202020204"/>
               </a:rPr>
               <a:t>/habits/{id}</a:t>
             </a:r>
@@ -16484,10 +16484,10 @@
                 <a:solidFill>
                   <a:srgbClr val="666666"/>
                 </a:solidFill>
-                <a:latin typeface="Songti SC"/>
-                <a:ea typeface="Songti SC"/>
-                <a:cs typeface="Songti SC"/>
-                <a:sym typeface="Songti SC"/>
+                <a:latin typeface="Arial" panose="020B0604020202020204"/>
+                <a:ea typeface="Arial" panose="020B0604020202020204"/>
+                <a:cs typeface="Arial" panose="020B0604020202020204"/>
+                <a:sym typeface="Arial" panose="020B0604020202020204"/>
               </a:rPr>
               <a:t>Delete a habit</a:t>
             </a:r>
@@ -16584,10 +16584,10 @@
                 <a:solidFill>
                   <a:srgbClr val="333333"/>
                 </a:solidFill>
-                <a:latin typeface="Songti SC"/>
-                <a:ea typeface="Songti SC"/>
-                <a:cs typeface="Songti SC"/>
-                <a:sym typeface="Songti SC"/>
+                <a:latin typeface="Arial" panose="020B0604020202020204"/>
+                <a:ea typeface="Arial" panose="020B0604020202020204"/>
+                <a:cs typeface="Arial" panose="020B0604020202020204"/>
+                <a:sym typeface="Arial" panose="020B0604020202020204"/>
               </a:rPr>
               <a:t>/habits/stats</a:t>
             </a:r>
@@ -16631,10 +16631,10 @@
                 <a:solidFill>
                   <a:srgbClr val="666666"/>
                 </a:solidFill>
-                <a:latin typeface="Songti SC"/>
-                <a:ea typeface="Songti SC"/>
-                <a:cs typeface="Songti SC"/>
-                <a:sym typeface="Songti SC"/>
+                <a:latin typeface="Arial" panose="020B0604020202020204"/>
+                <a:ea typeface="Arial" panose="020B0604020202020204"/>
+                <a:cs typeface="Arial" panose="020B0604020202020204"/>
+                <a:sym typeface="Arial" panose="020B0604020202020204"/>
               </a:rPr>
               <a:t>Get habit statistics</a:t>
             </a:r>
@@ -16752,10 +16752,10 @@
                 <a:solidFill>
                   <a:srgbClr val="333333"/>
                 </a:solidFill>
-                <a:latin typeface="Songti SC"/>
-                <a:ea typeface="Songti SC"/>
-                <a:cs typeface="Songti SC"/>
-                <a:sym typeface="Songti SC"/>
+                <a:latin typeface="Arial" panose="020B0604020202020204"/>
+                <a:ea typeface="Arial" panose="020B0604020202020204"/>
+                <a:cs typeface="Arial" panose="020B0604020202020204"/>
+                <a:sym typeface="Arial" panose="020B0604020202020204"/>
               </a:rPr>
               <a:t>JSON Format</a:t>
             </a:r>
@@ -16772,10 +16772,10 @@
                 <a:solidFill>
                   <a:srgbClr val="666666"/>
                 </a:solidFill>
-                <a:latin typeface="Songti SC"/>
-                <a:ea typeface="Songti SC"/>
-                <a:cs typeface="Songti SC"/>
-                <a:sym typeface="Songti SC"/>
+                <a:latin typeface="Arial" panose="020B0604020202020204"/>
+                <a:ea typeface="Arial" panose="020B0604020202020204"/>
+                <a:cs typeface="Arial" panose="020B0604020202020204"/>
+                <a:sym typeface="Arial" panose="020B0604020202020204"/>
               </a:rPr>
               <a:t>All data exchange</a:t>
             </a:r>
@@ -16783,10 +16783,10 @@
               <a:solidFill>
                 <a:srgbClr val="666666"/>
               </a:solidFill>
-              <a:latin typeface="Songti SC"/>
-              <a:ea typeface="Songti SC"/>
-              <a:cs typeface="Songti SC"/>
-              <a:sym typeface="Songti SC"/>
+              <a:latin typeface="Arial" panose="020B0604020202020204"/>
+              <a:ea typeface="Arial" panose="020B0604020202020204"/>
+              <a:cs typeface="Arial" panose="020B0604020202020204"/>
+              <a:sym typeface="Arial" panose="020B0604020202020204"/>
             </a:endParaRPr>
           </a:p>
         </p:txBody>
@@ -16901,10 +16901,10 @@
                 <a:solidFill>
                   <a:srgbClr val="333333"/>
                 </a:solidFill>
-                <a:latin typeface="Songti SC"/>
-                <a:ea typeface="Songti SC"/>
-                <a:cs typeface="Songti SC"/>
-                <a:sym typeface="Songti SC"/>
+                <a:latin typeface="Arial" panose="020B0604020202020204"/>
+                <a:ea typeface="Arial" panose="020B0604020202020204"/>
+                <a:cs typeface="Arial" panose="020B0604020202020204"/>
+                <a:sym typeface="Arial" panose="020B0604020202020204"/>
               </a:rPr>
               <a:t>HTTP Status</a:t>
             </a:r>
@@ -16921,10 +16921,10 @@
                 <a:solidFill>
                   <a:srgbClr val="666666"/>
                 </a:solidFill>
-                <a:latin typeface="Songti SC"/>
-                <a:ea typeface="Songti SC"/>
-                <a:cs typeface="Songti SC"/>
-                <a:sym typeface="Songti SC"/>
+                <a:latin typeface="Arial" panose="020B0604020202020204"/>
+                <a:ea typeface="Arial" panose="020B0604020202020204"/>
+                <a:cs typeface="Arial" panose="020B0604020202020204"/>
+                <a:sym typeface="Arial" panose="020B0604020202020204"/>
               </a:rPr>
               <a:t>200, 201, 404, etc.</a:t>
             </a:r>
@@ -16932,10 +16932,10 @@
               <a:solidFill>
                 <a:srgbClr val="666666"/>
               </a:solidFill>
-              <a:latin typeface="Songti SC"/>
-              <a:ea typeface="Songti SC"/>
-              <a:cs typeface="Songti SC"/>
-              <a:sym typeface="Songti SC"/>
+              <a:latin typeface="Arial" panose="020B0604020202020204"/>
+              <a:ea typeface="Arial" panose="020B0604020202020204"/>
+              <a:cs typeface="Arial" panose="020B0604020202020204"/>
+              <a:sym typeface="Arial" panose="020B0604020202020204"/>
             </a:endParaRPr>
           </a:p>
         </p:txBody>
@@ -17020,10 +17020,10 @@
                 <a:solidFill>
                   <a:srgbClr val="333333"/>
                 </a:solidFill>
-                <a:latin typeface="Songti SC"/>
-                <a:ea typeface="Songti SC"/>
-                <a:cs typeface="Songti SC"/>
-                <a:sym typeface="Songti SC"/>
+                <a:latin typeface="Arial" panose="020B0604020202020204"/>
+                <a:ea typeface="Arial" panose="020B0604020202020204"/>
+                <a:cs typeface="Arial" panose="020B0604020202020204"/>
+                <a:sym typeface="Arial" panose="020B0604020202020204"/>
               </a:rPr>
               <a:t>Interactive API Doc Preview</a:t>
             </a:r>
@@ -17144,10 +17144,10 @@
                 <a:solidFill>
                   <a:srgbClr val="808080"/>
                 </a:solidFill>
-                <a:latin typeface="Songti SC"/>
-                <a:ea typeface="Songti SC"/>
-                <a:cs typeface="Songti SC"/>
-                <a:sym typeface="Songti SC"/>
+                <a:latin typeface="Arial" panose="020B0604020202020204"/>
+                <a:ea typeface="Arial" panose="020B0604020202020204"/>
+                <a:cs typeface="Arial" panose="020B0604020202020204"/>
+                <a:sym typeface="Arial" panose="020B0604020202020204"/>
               </a:rPr>
               <a:t>Live documentation view powered by Swagger UI</a:t>
             </a:r>
@@ -17222,7 +17222,7 @@
           </a:ln>
         </p:spPr>
         <p:txBody>
-          <a:bodyPr vert="horz" wrap="square" lIns="63500" tIns="63500" rIns="63500" bIns="63500" rtlCol="0" anchor="ctr"/>
+          <a:bodyPr vert="horz" wrap="square" lIns="0" tIns="0" rIns="0" bIns="0" rtlCol="0" anchor="ctr" anchorCtr="0"/>
           <a:lstStyle/>
           <a:p>
             <a:pPr algn="ctr">
@@ -17267,10 +17267,10 @@
                 <a:solidFill>
                   <a:srgbClr val="333333"/>
                 </a:solidFill>
-                <a:latin typeface="Songti SC"/>
-                <a:ea typeface="Songti SC"/>
-                <a:cs typeface="Songti SC"/>
-                <a:sym typeface="Songti SC"/>
+                <a:latin typeface="Arial" panose="020B0604020202020204"/>
+                <a:ea typeface="Arial" panose="020B0604020202020204"/>
+                <a:cs typeface="Arial" panose="020B0604020202020204"/>
+                <a:sym typeface="Arial" panose="020B0604020202020204"/>
               </a:rPr>
               <a:t>Data Management &amp; Robustness</a:t>
             </a:r>
@@ -17466,10 +17466,10 @@
                 <a:solidFill>
                   <a:srgbClr val="1ABC9C"/>
                 </a:solidFill>
-                <a:latin typeface="Songti SC"/>
-                <a:ea typeface="Songti SC"/>
-                <a:cs typeface="Songti SC"/>
-                <a:sym typeface="Songti SC"/>
+                <a:latin typeface="Arial" panose="020B0604020202020204"/>
+                <a:ea typeface="Arial" panose="020B0604020202020204"/>
+                <a:cs typeface="Arial" panose="020B0604020202020204"/>
+                <a:sym typeface="Arial" panose="020B0604020202020204"/>
               </a:rPr>
               <a:t>Database Configuration</a:t>
             </a:r>
@@ -17513,10 +17513,10 @@
                 <a:solidFill>
                   <a:srgbClr val="555555"/>
                 </a:solidFill>
-                <a:latin typeface="Songti SC"/>
-                <a:ea typeface="Songti SC"/>
-                <a:cs typeface="Songti SC"/>
-                <a:sym typeface="Songti SC"/>
+                <a:latin typeface="Arial" panose="020B0604020202020204"/>
+                <a:ea typeface="Arial" panose="020B0604020202020204"/>
+                <a:cs typeface="Arial" panose="020B0604020202020204"/>
+                <a:sym typeface="Arial" panose="020B0604020202020204"/>
               </a:rPr>
               <a:t>Utilizes H2 (in-memory) for rapid testing cycles and Spring Data JPA to eliminate repetitive JDBC boilerplate code, streamlining all CRUD operations.</a:t>
             </a:r>
@@ -17672,10 +17672,10 @@
                 <a:solidFill>
                   <a:srgbClr val="1ABC9C"/>
                 </a:solidFill>
-                <a:latin typeface="Songti SC"/>
-                <a:ea typeface="Songti SC"/>
-                <a:cs typeface="Songti SC"/>
-                <a:sym typeface="Songti SC"/>
+                <a:latin typeface="Arial" panose="020B0604020202020204"/>
+                <a:ea typeface="Arial" panose="020B0604020202020204"/>
+                <a:cs typeface="Arial" panose="020B0604020202020204"/>
+                <a:sym typeface="Arial" panose="020B0604020202020204"/>
               </a:rPr>
               <a:t>Data Validation</a:t>
             </a:r>
@@ -17719,10 +17719,10 @@
                 <a:solidFill>
                   <a:srgbClr val="555555"/>
                 </a:solidFill>
-                <a:latin typeface="Songti SC"/>
-                <a:ea typeface="Songti SC"/>
-                <a:cs typeface="Songti SC"/>
-                <a:sym typeface="Songti SC"/>
+                <a:latin typeface="Arial" panose="020B0604020202020204"/>
+                <a:ea typeface="Arial" panose="020B0604020202020204"/>
+                <a:cs typeface="Arial" panose="020B0604020202020204"/>
+                <a:sym typeface="Arial" panose="020B0604020202020204"/>
               </a:rPr>
               <a:t>Integrated Jakarta Validation (Bean Validation) enforces strict data integrity rules (e.g., @NotBlank, @Min) to ensure all incoming API payloads meet business criteria.</a:t>
             </a:r>
@@ -17878,10 +17878,10 @@
                 <a:solidFill>
                   <a:srgbClr val="1ABC9C"/>
                 </a:solidFill>
-                <a:latin typeface="Songti SC"/>
-                <a:ea typeface="Songti SC"/>
-                <a:cs typeface="Songti SC"/>
-                <a:sym typeface="Songti SC"/>
+                <a:latin typeface="Arial" panose="020B0604020202020204"/>
+                <a:ea typeface="Arial" panose="020B0604020202020204"/>
+                <a:cs typeface="Arial" panose="020B0604020202020204"/>
+                <a:sym typeface="Arial" panose="020B0604020202020204"/>
               </a:rPr>
               <a:t>Global Exception Handling</a:t>
             </a:r>
@@ -17925,10 +17925,10 @@
                 <a:solidFill>
                   <a:srgbClr val="555555"/>
                 </a:solidFill>
-                <a:latin typeface="Songti SC"/>
-                <a:ea typeface="Songti SC"/>
-                <a:cs typeface="Songti SC"/>
-                <a:sym typeface="Songti SC"/>
+                <a:latin typeface="Arial" panose="020B0604020202020204"/>
+                <a:ea typeface="Arial" panose="020B0604020202020204"/>
+                <a:cs typeface="Arial" panose="020B0604020202020204"/>
+                <a:sym typeface="Arial" panose="020B0604020202020204"/>
               </a:rPr>
               <a:t>A centralized @RestControllerAdvice catches all exceptions, providing consistent, well-structured JSON error responses to improve API usability for consumers.</a:t>
             </a:r>
@@ -18048,10 +18048,10 @@
                 <a:solidFill>
                   <a:srgbClr val="333333"/>
                 </a:solidFill>
-                <a:latin typeface="Songti SC"/>
-                <a:ea typeface="Songti SC"/>
-                <a:cs typeface="Songti SC"/>
-                <a:sym typeface="Songti SC"/>
+                <a:latin typeface="Arial" panose="020B0604020202020204"/>
+                <a:ea typeface="Arial" panose="020B0604020202020204"/>
+                <a:cs typeface="Arial" panose="020B0604020202020204"/>
+                <a:sym typeface="Arial" panose="020B0604020202020204"/>
               </a:rPr>
               <a:t>Quality Assurance &amp; Maintainability</a:t>
             </a:r>
@@ -18176,10 +18176,10 @@
                 <a:solidFill>
                   <a:srgbClr val="1ABC9C"/>
                 </a:solidFill>
-                <a:latin typeface="Songti SC"/>
-                <a:ea typeface="Songti SC"/>
-                <a:cs typeface="Songti SC"/>
-                <a:sym typeface="Songti SC"/>
+                <a:latin typeface="Arial" panose="020B0604020202020204"/>
+                <a:ea typeface="Arial" panose="020B0604020202020204"/>
+                <a:cs typeface="Arial" panose="020B0604020202020204"/>
+                <a:sym typeface="Arial" panose="020B0604020202020204"/>
               </a:rPr>
               <a:t>API Documentation (Swagger UI)</a:t>
             </a:r>
@@ -18223,10 +18223,10 @@
                 <a:solidFill>
                   <a:srgbClr val="555555"/>
                 </a:solidFill>
-                <a:latin typeface="Songti SC"/>
-                <a:ea typeface="Songti SC"/>
-                <a:cs typeface="Songti SC"/>
-                <a:sym typeface="Songti SC"/>
+                <a:latin typeface="Arial" panose="020B0604020202020204"/>
+                <a:ea typeface="Arial" panose="020B0604020202020204"/>
+                <a:cs typeface="Arial" panose="020B0604020202020204"/>
+                <a:sym typeface="Arial" panose="020B0604020202020204"/>
               </a:rPr>
               <a:t>Springdoc-OpenAPI:</a:t>
             </a:r>
@@ -18235,10 +18235,10 @@
                 <a:solidFill>
                   <a:srgbClr val="555555"/>
                 </a:solidFill>
-                <a:latin typeface="Songti SC"/>
-                <a:ea typeface="Songti SC"/>
-                <a:cs typeface="Songti SC"/>
-                <a:sym typeface="Songti SC"/>
+                <a:latin typeface="Arial" panose="020B0604020202020204"/>
+                <a:ea typeface="Arial" panose="020B0604020202020204"/>
+                <a:cs typeface="Arial" panose="020B0604020202020204"/>
+                <a:sym typeface="Arial" panose="020B0604020202020204"/>
               </a:rPr>
               <a:t>Auto-generates interactive docs from code annotations.</a:t>
             </a:r>
@@ -18255,10 +18255,10 @@
                 <a:solidFill>
                   <a:srgbClr val="555555"/>
                 </a:solidFill>
-                <a:latin typeface="Songti SC"/>
-                <a:ea typeface="Songti SC"/>
-                <a:cs typeface="Songti SC"/>
-                <a:sym typeface="Songti SC"/>
+                <a:latin typeface="Arial" panose="020B0604020202020204"/>
+                <a:ea typeface="Arial" panose="020B0604020202020204"/>
+                <a:cs typeface="Arial" panose="020B0604020202020204"/>
+                <a:sym typeface="Arial" panose="020B0604020202020204"/>
               </a:rPr>
               <a:t>Benefit:</a:t>
             </a:r>
@@ -18267,10 +18267,10 @@
                 <a:solidFill>
                   <a:srgbClr val="555555"/>
                 </a:solidFill>
-                <a:latin typeface="Songti SC"/>
-                <a:ea typeface="Songti SC"/>
-                <a:cs typeface="Songti SC"/>
-                <a:sym typeface="Songti SC"/>
+                <a:latin typeface="Arial" panose="020B0604020202020204"/>
+                <a:ea typeface="Arial" panose="020B0604020202020204"/>
+                <a:cs typeface="Arial" panose="020B0604020202020204"/>
+                <a:sym typeface="Arial" panose="020B0604020202020204"/>
               </a:rPr>
               <a:t>Provides a live interface for developers to explore, test, and understand API endpoints visually.</a:t>
             </a:r>
@@ -18278,10 +18278,10 @@
               <a:solidFill>
                 <a:srgbClr val="555555"/>
               </a:solidFill>
-              <a:latin typeface="Songti SC"/>
-              <a:ea typeface="Songti SC"/>
-              <a:cs typeface="Songti SC"/>
-              <a:sym typeface="Songti SC"/>
+              <a:latin typeface="Arial" panose="020B0604020202020204"/>
+              <a:ea typeface="Arial" panose="020B0604020202020204"/>
+              <a:cs typeface="Arial" panose="020B0604020202020204"/>
+              <a:sym typeface="Arial" panose="020B0604020202020204"/>
             </a:endParaRPr>
           </a:p>
         </p:txBody>
@@ -18403,10 +18403,10 @@
                 <a:solidFill>
                   <a:srgbClr val="1ABC9C"/>
                 </a:solidFill>
-                <a:latin typeface="Songti SC"/>
-                <a:ea typeface="Songti SC"/>
-                <a:cs typeface="Songti SC"/>
-                <a:sym typeface="Songti SC"/>
+                <a:latin typeface="Arial" panose="020B0604020202020204"/>
+                <a:ea typeface="Arial" panose="020B0604020202020204"/>
+                <a:cs typeface="Arial" panose="020B0604020202020204"/>
+                <a:sym typeface="Arial" panose="020B0604020202020204"/>
               </a:rPr>
               <a:t>Sample Data Initialization</a:t>
             </a:r>
@@ -18450,10 +18450,10 @@
                 <a:solidFill>
                   <a:srgbClr val="555555"/>
                 </a:solidFill>
-                <a:latin typeface="Songti SC"/>
-                <a:ea typeface="Songti SC"/>
-                <a:cs typeface="Songti SC"/>
-                <a:sym typeface="Songti SC"/>
+                <a:latin typeface="Arial" panose="020B0604020202020204"/>
+                <a:ea typeface="Arial" panose="020B0604020202020204"/>
+                <a:cs typeface="Arial" panose="020B0604020202020204"/>
+                <a:sym typeface="Arial" panose="020B0604020202020204"/>
               </a:rPr>
               <a:t>A</a:t>
             </a:r>
@@ -18462,10 +18462,10 @@
                 <a:solidFill>
                   <a:srgbClr val="555555"/>
                 </a:solidFill>
-                <a:latin typeface="Songti SC"/>
-                <a:ea typeface="Songti SC"/>
-                <a:cs typeface="Songti SC"/>
-                <a:sym typeface="Songti SC"/>
+                <a:latin typeface="Arial" panose="020B0604020202020204"/>
+                <a:ea typeface="Arial" panose="020B0604020202020204"/>
+                <a:cs typeface="Arial" panose="020B0604020202020204"/>
+                <a:sym typeface="Arial" panose="020B0604020202020204"/>
               </a:rPr>
               <a:t>CommandLineRunner</a:t>
             </a:r>
@@ -18474,10 +18474,10 @@
                 <a:solidFill>
                   <a:srgbClr val="555555"/>
                 </a:solidFill>
-                <a:latin typeface="Songti SC"/>
-                <a:ea typeface="Songti SC"/>
-                <a:cs typeface="Songti SC"/>
-                <a:sym typeface="Songti SC"/>
+                <a:latin typeface="Arial" panose="020B0604020202020204"/>
+                <a:ea typeface="Arial" panose="020B0604020202020204"/>
+                <a:cs typeface="Arial" panose="020B0604020202020204"/>
+                <a:sym typeface="Arial" panose="020B0604020202020204"/>
               </a:rPr>
               <a:t>bean loads predefined test data into the H2 in-memory database on startup, enabling immediate functional testing without manual setup.</a:t>
             </a:r>
@@ -18602,10 +18602,10 @@
                 <a:solidFill>
                   <a:srgbClr val="1ABC9C"/>
                 </a:solidFill>
-                <a:latin typeface="Songti SC"/>
-                <a:ea typeface="Songti SC"/>
-                <a:cs typeface="Songti SC"/>
-                <a:sym typeface="Songti SC"/>
+                <a:latin typeface="Arial" panose="020B0604020202020204"/>
+                <a:ea typeface="Arial" panose="020B0604020202020204"/>
+                <a:cs typeface="Arial" panose="020B0604020202020204"/>
+                <a:sym typeface="Arial" panose="020B0604020202020204"/>
               </a:rPr>
               <a:t>Version Control (Git)</a:t>
             </a:r>
@@ -18649,10 +18649,10 @@
                 <a:solidFill>
                   <a:srgbClr val="555555"/>
                 </a:solidFill>
-                <a:latin typeface="Songti SC"/>
-                <a:ea typeface="Songti SC"/>
-                <a:cs typeface="Songti SC"/>
-                <a:sym typeface="Songti SC"/>
+                <a:latin typeface="Arial" panose="020B0604020202020204"/>
+                <a:ea typeface="Arial" panose="020B0604020202020204"/>
+                <a:cs typeface="Arial" panose="020B0604020202020204"/>
+                <a:sym typeface="Arial" panose="020B0604020202020204"/>
               </a:rPr>
               <a:t>Used for full lifecycle source code management, ensuring a complete, immutable history of changes and facilitating seamless team collaboration.</a:t>
             </a:r>
@@ -18776,10 +18776,10 @@
                 <a:solidFill>
                   <a:srgbClr val="808080"/>
                 </a:solidFill>
-                <a:latin typeface="Songti SC"/>
-                <a:ea typeface="Songti SC"/>
-                <a:cs typeface="Songti SC"/>
-                <a:sym typeface="Songti SC"/>
+                <a:latin typeface="Arial" panose="020B0604020202020204"/>
+                <a:ea typeface="Arial" panose="020B0604020202020204"/>
+                <a:cs typeface="Arial" panose="020B0604020202020204"/>
+                <a:sym typeface="Arial" panose="020B0604020202020204"/>
               </a:rPr>
               <a:t>Standard Git Workflow: Pull → Commit → Push → Merge</a:t>
             </a:r>
@@ -18803,8 +18803,8 @@
         </p:blipFill>
         <p:spPr>
           <a:xfrm>
-            <a:off x="6159500" y="2275205"/>
-            <a:ext cx="4942840" cy="3260090"/>
+            <a:off x="6283325" y="2463800"/>
+            <a:ext cx="4765675" cy="3143885"/>
           </a:xfrm>
           <a:prstGeom prst="rect">
             <a:avLst/>
@@ -18923,10 +18923,10 @@
                 <a:solidFill>
                   <a:srgbClr val="FFFFFF"/>
                 </a:solidFill>
-                <a:latin typeface="Songti SC"/>
-                <a:ea typeface="Songti SC"/>
-                <a:cs typeface="Songti SC"/>
-                <a:sym typeface="Songti SC"/>
+                <a:latin typeface="Arial" panose="020B0604020202020204"/>
+                <a:ea typeface="Arial" panose="020B0604020202020204"/>
+                <a:cs typeface="Arial" panose="020B0604020202020204"/>
+                <a:sym typeface="Arial" panose="020B0604020202020204"/>
               </a:rPr>
               <a:t>Technical Choices, Reflection, and Conclusion</a:t>
             </a:r>
@@ -19044,10 +19044,10 @@
                 <a:solidFill>
                   <a:srgbClr val="FFFFFF"/>
                 </a:solidFill>
-                <a:latin typeface="Songti SC"/>
-                <a:ea typeface="Songti SC"/>
-                <a:cs typeface="Songti SC"/>
-                <a:sym typeface="Songti SC"/>
+                <a:latin typeface="Arial" panose="020B0604020202020204"/>
+                <a:ea typeface="Arial" panose="020B0604020202020204"/>
+                <a:cs typeface="Arial" panose="020B0604020202020204"/>
+                <a:sym typeface="Arial" panose="020B0604020202020204"/>
               </a:rPr>
               <a:t>Rationale for Choices</a:t>
             </a:r>
@@ -19091,10 +19091,10 @@
                 <a:solidFill>
                   <a:srgbClr val="E0E0E0"/>
                 </a:solidFill>
-                <a:latin typeface="Songti SC"/>
-                <a:ea typeface="Songti SC"/>
-                <a:cs typeface="Songti SC"/>
-                <a:sym typeface="Songti SC"/>
+                <a:latin typeface="Arial" panose="020B0604020202020204"/>
+                <a:ea typeface="Arial" panose="020B0604020202020204"/>
+                <a:cs typeface="Arial" panose="020B0604020202020204"/>
+                <a:sym typeface="Arial" panose="020B0604020202020204"/>
               </a:rPr>
               <a:t>Selected</a:t>
             </a:r>
@@ -19103,10 +19103,10 @@
                 <a:solidFill>
                   <a:srgbClr val="E0E0E0"/>
                 </a:solidFill>
-                <a:latin typeface="Songti SC"/>
-                <a:ea typeface="Songti SC"/>
-                <a:cs typeface="Songti SC"/>
-                <a:sym typeface="Songti SC"/>
+                <a:latin typeface="Arial" panose="020B0604020202020204"/>
+                <a:ea typeface="Arial" panose="020B0604020202020204"/>
+                <a:cs typeface="Arial" panose="020B0604020202020204"/>
+                <a:sym typeface="Arial" panose="020B0604020202020204"/>
               </a:rPr>
               <a:t>Java &amp; Spring Boot</a:t>
             </a:r>
@@ -19115,10 +19115,10 @@
                 <a:solidFill>
                   <a:srgbClr val="E0E0E0"/>
                 </a:solidFill>
-                <a:latin typeface="Songti SC"/>
-                <a:ea typeface="Songti SC"/>
-                <a:cs typeface="Songti SC"/>
-                <a:sym typeface="Songti SC"/>
+                <a:latin typeface="Arial" panose="020B0604020202020204"/>
+                <a:ea typeface="Arial" panose="020B0604020202020204"/>
+                <a:cs typeface="Arial" panose="020B0604020202020204"/>
+                <a:sym typeface="Arial" panose="020B0604020202020204"/>
               </a:rPr>
               <a:t>for familiarity. The robust ecosystem enabled focus on core API design, persistence logic, and overall project structure.</a:t>
             </a:r>
@@ -19236,10 +19236,10 @@
                 <a:solidFill>
                   <a:srgbClr val="FFFFFF"/>
                 </a:solidFill>
-                <a:latin typeface="Songti SC"/>
-                <a:ea typeface="Songti SC"/>
-                <a:cs typeface="Songti SC"/>
-                <a:sym typeface="Songti SC"/>
+                <a:latin typeface="Arial" panose="020B0604020202020204"/>
+                <a:ea typeface="Arial" panose="020B0604020202020204"/>
+                <a:cs typeface="Arial" panose="020B0604020202020204"/>
+                <a:sym typeface="Arial" panose="020B0604020202020204"/>
               </a:rPr>
               <a:t>Project Reflection</a:t>
             </a:r>
@@ -19283,10 +19283,10 @@
                 <a:solidFill>
                   <a:srgbClr val="E0E0E0"/>
                 </a:solidFill>
-                <a:latin typeface="Songti SC"/>
-                <a:ea typeface="Songti SC"/>
-                <a:cs typeface="Songti SC"/>
-                <a:sym typeface="Songti SC"/>
+                <a:latin typeface="Arial" panose="020B0604020202020204"/>
+                <a:ea typeface="Arial" panose="020B0604020202020204"/>
+                <a:cs typeface="Arial" panose="020B0604020202020204"/>
+                <a:sym typeface="Arial" panose="020B0604020202020204"/>
               </a:rPr>
               <a:t>Successfully built a fully functional REST API. Mastered DTO patterns for clean contracts, implemented global exception handling, and automated API documentation effectively.</a:t>
             </a:r>
@@ -19404,10 +19404,10 @@
                 <a:solidFill>
                   <a:srgbClr val="FFFFFF"/>
                 </a:solidFill>
-                <a:latin typeface="Songti SC"/>
-                <a:ea typeface="Songti SC"/>
-                <a:cs typeface="Songti SC"/>
-                <a:sym typeface="Songti SC"/>
+                <a:latin typeface="Arial" panose="020B0604020202020204"/>
+                <a:ea typeface="Arial" panose="020B0604020202020204"/>
+                <a:cs typeface="Arial" panose="020B0604020202020204"/>
+                <a:sym typeface="Arial" panose="020B0604020202020204"/>
               </a:rPr>
               <a:t>Key Conclusions</a:t>
             </a:r>
@@ -19451,10 +19451,10 @@
                 <a:solidFill>
                   <a:srgbClr val="E0E0E0"/>
                 </a:solidFill>
-                <a:latin typeface="Songti SC"/>
-                <a:ea typeface="Songti SC"/>
-                <a:cs typeface="Songti SC"/>
-                <a:sym typeface="Songti SC"/>
+                <a:latin typeface="Arial" panose="020B0604020202020204"/>
+                <a:ea typeface="Arial" panose="020B0604020202020204"/>
+                <a:cs typeface="Arial" panose="020B0604020202020204"/>
+                <a:sym typeface="Arial" panose="020B0604020202020204"/>
               </a:rPr>
               <a:t>The project fully meets all coursework requirements. It provides a solid foundation for future extensions, such as user auth, complex statistics, or a full frontend.</a:t>
             </a:r>
@@ -19498,10 +19498,10 @@
                 <a:solidFill>
                   <a:srgbClr val="FFFFFF"/>
                 </a:solidFill>
-                <a:latin typeface="Songti SC"/>
-                <a:ea typeface="Songti SC"/>
-                <a:cs typeface="Songti SC"/>
-                <a:sym typeface="Songti SC"/>
+                <a:latin typeface="Arial" panose="020B0604020202020204"/>
+                <a:ea typeface="Arial" panose="020B0604020202020204"/>
+                <a:cs typeface="Arial" panose="020B0604020202020204"/>
+                <a:sym typeface="Arial" panose="020B0604020202020204"/>
               </a:rPr>
               <a:t>THANK YOU</a:t>
             </a:r>
@@ -19545,10 +19545,10 @@
                 <a:solidFill>
                   <a:srgbClr val="06E0C3"/>
                 </a:solidFill>
-                <a:latin typeface="Songti SC"/>
-                <a:ea typeface="Songti SC"/>
-                <a:cs typeface="Songti SC"/>
-                <a:sym typeface="Songti SC"/>
+                <a:latin typeface="Arial" panose="020B0604020202020204"/>
+                <a:ea typeface="Arial" panose="020B0604020202020204"/>
+                <a:cs typeface="Arial" panose="020B0604020202020204"/>
+                <a:sym typeface="Arial" panose="020B0604020202020204"/>
               </a:rPr>
               <a:t>Q&amp;A SESSION / ANY QUESTIONS?</a:t>
             </a:r>

</xml_diff>